<commit_message>
Refine documentation and presentation metadata
</commit_message>
<xml_diff>
--- a/output/presentation/economic-neighbors-v3.pptx
+++ b/output/presentation/economic-neighbors-v3.pptx
@@ -166,9 +166,9 @@
 </file>
 
 <file path=ppt/notesMasters/theme/theme3.xml><?xml version="1.0" encoding="utf-8"?>
-<a:theme xmlns:a="http://schemas.openxmlformats.org/drawingml/2006/main" name="ChatGPT">
+<a:theme xmlns:a="http://schemas.openxmlformats.org/drawingml/2006/main" name="Economic Neighbors">
   <a:themeElements>
-    <a:clrScheme name="ChatGPT">
+    <a:clrScheme name="Economic Neighbors">
       <a:dk1>
         <a:srgbClr val="000000"/>
       </a:dk1>
@@ -218,7 +218,7 @@
         <a:cs typeface=""/>
       </a:minorFont>
     </a:fontScheme>
-    <a:fmtScheme name="ChatGPT">
+    <a:fmtScheme name="Economic Neighbors">
       <a:fillStyleLst>
         <a:solidFill>
           <a:schemeClr val="phClr"/>
@@ -460,7 +460,7 @@
           </a:p>
           <a:p xmlns:a="http://schemas.openxmlformats.org/drawingml/2006/main">
             <a:r>
-              <a:t>Краткий конкурсный обзор. Направление «Кластеризация». Полная панель 2016 МО, январь 2023–декабрь 2024. Код и результаты подготовлены с помощью Codex.</a:t>
+              <a:t>Конкурс СберИндекса, направление «Кластеризация». Полная панель: 2 016 муниципалитетов, январь 2023 - декабрь 2024. Цель: найти потребительские аналоги территорий и проследить изменения групп.</a:t>
             </a:r>
           </a:p>
         </p:txBody>
@@ -540,7 +540,7 @@
           </a:p>
           <a:p xmlns:a="http://schemas.openxmlformats.org/drawingml/2006/main">
             <a:r>
-              <a:t>Исходные 303126 строк, 2190 МО, 6 категорий, 24 месяца. 12234 отсутствующих строк. 174 МО исключены. territory_id идентифицирует неизменные границы. Доли нормированы на сумму пяти непересекающихся категорий. x=sqrt(p). w_ij=exp(-d_ij²/(sigma_i sigma_j)), union kNN, no self-loops.</a:t>
+              <a:t>Исходная таблица содержит 303 126 строк, 2 190 МО, шесть категорий и 24 месяца. Отсутствуют 12 234 комбинации МО, месяца и категории. Для временного сравнения исключены 174 МО с неполной историей. territory_id обозначает неизменную территорию. Доли рассчитаны от суммы пяти выбранных категорий. Признаки x = sqrt(p). Вес ребра w_ij = exp(-d_ij²/(sigma_i sigma_j)); сеть объединяет kNN в обоих направлениях, петли исключены.</a:t>
             </a:r>
           </a:p>
         </p:txBody>
@@ -620,7 +620,7 @@
           </a:p>
           <a:p xmlns:a="http://schemas.openxmlformats.org/drawingml/2006/main">
             <a:r>
-              <a:t>27 конфигураций в полном поиске. В таблице лучший по SW вариант каждого метода при k=30 и минимальной доле группы 2%. SW на фиксированной выборке 2000 из 2016 МО. Остальные метрики на всех 2016. S_Dbw: дисперсии по формулам 11–17 Shahileh et al.2025 с индикатором внутри шара. AVI/AVU формулы18–21, MQ стандартная Qgamma1. https://doi.org/10.1134/S1064562425700589</a:t>
+              <a:t>Сравнены 27 конфигураций. Таблица показывает лучший по SW вариант каждого метода при kNN = 30 и минимальной доле группы 2%. SW рассчитан на фиксированной выборке 2 000 из 2 016 МО; остальные метрики используют всю панель. S_Dbw: векторы дисперсий по формулам 11-17 Shahileh et al. (2025), с подсчётом точек внутри шара. AVI и AVU: формулы 18-21; MQ: стандартная модулярность при gamma = 1. Первоисточник: https://doi.org/10.1134/S1064562425700589.</a:t>
             </a:r>
           </a:p>
         </p:txBody>
@@ -700,7 +700,7 @@
           </a:p>
           <a:p xmlns:a="http://schemas.openxmlformats.org/drawingml/2006/main">
             <a:r>
-              <a:t>Среднее долей с равным весом каждого из2016 МО. Это не национальная доля расходов. Выбранные категории не исчерпывают total. Январь2023 и декабрь2024 разные календарные месяцы, сезонность не очищена. Полная таблица120наблюдений в reviewed-snapshot basket.</a:t>
+              <a:t>Средние доли рассчитаны с равным весом каждого из 2 016 МО. Знаменатель включает пять выбранных категорий; показатель не является национальной долей всех расходов. Сравнение января 2023 с декабрём 2024 не очищено от сезонности. Исходные доли сохранены в outputs/analysis/model.npz; расчёт и график приведены в исследовательском ноутбуке.</a:t>
             </a:r>
           </a:p>
         </p:txBody>
@@ -780,7 +780,7 @@
           </a:p>
           <a:p xmlns:a="http://schemas.openxmlformats.org/drawingml/2006/main">
             <a:r>
-              <a:t>Сопоставление на одинаковых21 переходах: апрель2023-декабрь2024. Усредняются уровни за три месяца, затем пересчитываются доли и группы. Seed17,31,47 против42во всех24месяцах. МинимальныйARI0.9899289. СреднийодноимённыхмесяцевдвухлетARI0.542829.</a:t>
+              <a:t>Сравнение выполнено на 21 общем переходе: апрель 2023 - декабрь 2024. Сглаживание усредняет уровни за текущий и два предыдущих месяца; затем заново рассчитываются доли и группы. Seeds 17, 31 и 47 сопоставлены с seed 42 во всех 24 месяцах. Минимальный ARI равен 0,9899289. Средний ARI одинаковых календарных месяцев двух лет равен 0,542829.</a:t>
             </a:r>
           </a:p>
         </p:txBody>
@@ -860,7 +860,7 @@
           </a:p>
           <a:p xmlns:a="http://schemas.openxmlformats.org/drawingml/2006/main">
             <a:r>
-              <a:t>Декабрь2024. Общая выборка2004МО в крупнейшей дорожной компоненте. Spectral,K3,kNN30. ОценкаSWв одном пространстве sqrtдолей. Дорожные расстояния статическийсрезконца2024. Вывод только обаналогахпотребления, некачестве дорог.</a:t>
+              <a:t>Декабрь 2024. Общая выборка: 2 004 МО крупнейшей дорожной компоненты. Для всех определений близости использованы Spectral, K = 3 и kNN = 30. SW оценивается в одном пространстве квадратных корней долей. Дорожные расстояния относятся к концу 2024 года. Вывод касается подбора потребительских аналогов и не оценивает качество дорог.</a:t>
             </a:r>
           </a:p>
         </p:txBody>
@@ -940,7 +940,7 @@
           </a:p>
           <a:p xmlns:a="http://schemas.openxmlformats.org/drawingml/2006/main">
             <a:r>
-              <a:t>Spearman с доступностью2024 и среднимипо12месяцам долями2024 на2004МО сизвестнымпоказателем. Другаяправилоотбора, чемдорожнаякомпонента. Показательнеучаствуетвобучении. Причинностьнеустановлена. Доли композиционны.</a:t>
+              <a:t>Spearman рассчитан между доступностью рынков за 2024 год и средними долями за 12 месяцев 2024 года. Выборка включает 2 004 МО с известным показателем доступности; правило отбора отличается от дорожного сравнения. Доступность не участвует в обучении. Причинный эффект не установлен; доли связаны общим знаменателем.</a:t>
             </a:r>
           </a:p>
         </p:txBody>
@@ -1020,7 +1020,7 @@
           </a:p>
           <a:p xmlns:a="http://schemas.openxmlformats.org/drawingml/2006/main">
             <a:r>
-              <a:t>Полная сеть2016МО,декабрь2024. Цветгруппысогласованповремени. PCAобученана январе2023,2компоненты85.7%дисперсии. ШестьреальныхсильнейшихрёбервыбранногоМО. Ихвесопределяетполное5мерноепространство. Не географическаямобильность. ДоликорзиныМайкопа47.4,6.4,30.5,6.8,8.9%.</a:t>
+              <a:t>Полная сеть: 2 016 МО, декабрь 2024. Цвет обозначает согласованную во времени группу. PCA обучена на январе 2023; две компоненты объясняют 85,7% дисперсии. На графике показаны шесть сильнейших реальных рёбер Майкопа. Их веса рассчитаны в полном пространстве пяти признаков. Доли корзины Майкопа: 47,4%, 6,4%, 30,5%, 6,8% и 8,9%.</a:t>
             </a:r>
           </a:p>
         </p:txBody>
@@ -1100,7 +1100,7 @@
           </a:p>
           <a:p xmlns:a="http://schemas.openxmlformats.org/drawingml/2006/main">
             <a:r>
-              <a:t>Данные/производныеCCBYSA4.0СберИндекс. НашалгоритмическийкодMIT. СмREADME,docs/methodological-report.md,docs/metrics.md,config.json,notebooks/economic-neighbors.ipynb. AIсодействие disclosed README. Пользовательдолженпроверитьсамостоятельностьпринятьответственность. ФормулыAVI/AVU https://doi.org/10.1134/S1064562425700589.</a:t>
+              <a:t>Данные и производные аналитические материалы: СберИндекс, CC BY-SA 4.0. Код алгоритмов и проверок: MIT. Для воспроизведения используются README.md, config.json, notebooks/economic-neighbors.ipynb и исходные данные по официальным ссылкам. Методология и ограничения: docs/methodological-report.md и docs/metrics.md. Формулы AVI и AVU: https://doi.org/10.1134/S1064562425700589.</a:t>
             </a:r>
           </a:p>
         </p:txBody>
@@ -3111,9 +3111,9 @@
 </file>
 
 <file path=ppt/slideMasters/theme/theme2.xml><?xml version="1.0" encoding="utf-8"?>
-<a:theme xmlns:a="http://schemas.openxmlformats.org/drawingml/2006/main" name="ChatGPT">
+<a:theme xmlns:a="http://schemas.openxmlformats.org/drawingml/2006/main" name="Economic Neighbors">
   <a:themeElements>
-    <a:clrScheme name="ChatGPT">
+    <a:clrScheme name="Economic Neighbors">
       <a:dk1>
         <a:srgbClr val="000000"/>
       </a:dk1>
@@ -3163,7 +3163,7 @@
         <a:cs typeface=""/>
       </a:minorFont>
     </a:fontScheme>
-    <a:fmtScheme name="ChatGPT">
+    <a:fmtScheme name="Economic Neighbors">
       <a:fillStyleLst>
         <a:solidFill>
           <a:schemeClr val="phClr"/>
@@ -23219,9 +23219,9 @@
 </file>
 
 <file path=ppt/theme/theme1.xml><?xml version="1.0" encoding="utf-8"?>
-<a:theme xmlns:a="http://schemas.openxmlformats.org/drawingml/2006/main" name="ChatGPT">
+<a:theme xmlns:a="http://schemas.openxmlformats.org/drawingml/2006/main" name="Economic Neighbors">
   <a:themeElements>
-    <a:clrScheme name="ChatGPT">
+    <a:clrScheme name="Economic Neighbors">
       <a:dk1>
         <a:srgbClr val="000000"/>
       </a:dk1>
@@ -23271,7 +23271,7 @@
         <a:cs typeface=""/>
       </a:minorFont>
     </a:fontScheme>
-    <a:fmtScheme name="ChatGPT">
+    <a:fmtScheme name="Economic Neighbors">
       <a:fillStyleLst>
         <a:solidFill>
           <a:schemeClr val="phClr"/>

</xml_diff>